<commit_message>
1.0.1: no false FAIL without PowerPoint; demo GIF; Gemini + Cursor manifests
- QA: "PowerPoint not installed" is no longer an error; LibreOffice pixel
  diffs are warnings (approximate renderer); ground truth still fails
- build/compile install missing brand-kit fonts per-user (--no-font-install
  to skip); QA flags kit-only fonts
- demo deck ships its OFL fonts; slide 1 card shows a real cover
- README: demo GIF from real output, measured time/token numbers
- gemini-extension.json, .cursor-plugin/plugin.json, Discussions link

Co-Authored-By: Claude Opus 5.5 <noreply@anthropic.com>
</commit_message>
<xml_diff>
--- a/examples/demo-deck/deck.pptx
+++ b/examples/demo-deck/deck.pptx
@@ -4790,7 +4790,7 @@
           </a:xfrm>
           <a:prstGeom prst="roundRect">
             <a:avLst>
-              <a:gd name="adj" fmla="val 20588"/>
+              <a:gd name="adj" fmla="val 13072"/>
             </a:avLst>
           </a:prstGeom>
           <a:solidFill>
@@ -4821,7 +4821,7 @@
           </a:xfrm>
           <a:prstGeom prst="roundRect">
             <a:avLst>
-              <a:gd name="adj" fmla="val 20588"/>
+              <a:gd name="adj" fmla="val 13072"/>
             </a:avLst>
           </a:prstGeom>
           <a:solidFill>
@@ -4852,7 +4852,7 @@
           </a:xfrm>
           <a:prstGeom prst="roundRect">
             <a:avLst>
-              <a:gd name="adj" fmla="val 20588"/>
+              <a:gd name="adj" fmla="val 13072"/>
             </a:avLst>
           </a:prstGeom>
           <a:solidFill>
@@ -4870,9 +4870,100 @@
           </a:p>
         </p:txBody>
       </p:sp>
-      <p:sp>
-        <p:nvSpPr>
-          <p:cNvPr id="5" name="Title"/>
+      <p:pic>
+        <p:nvPicPr>
+          <p:cNvPr id="5" name="Cover preview" descr="Fernway cover slide"/>
+          <p:cNvPicPr>
+            <a:picLocks noChangeAspect="1"/>
+          </p:cNvPicPr>
+          <p:nvPr/>
+        </p:nvPicPr>
+        <p:blipFill>
+          <a:blip r:embed="rId2"/>
+          <a:srcRect t="62" b="62"/>
+          <a:stretch>
+            <a:fillRect/>
+          </a:stretch>
+        </p:blipFill>
+        <p:spPr>
+          <a:xfrm>
+            <a:off x="8001000" y="1619250"/>
+            <a:ext cx="3390900" cy="1905000"/>
+          </a:xfrm>
+          <a:prstGeom prst="roundRect">
+            <a:avLst>
+              <a:gd name="adj" fmla="val 10000"/>
+            </a:avLst>
+          </a:prstGeom>
+        </p:spPr>
+      </p:pic>
+      <p:sp>
+        <p:nvSpPr>
+          <p:cNvPr id="6" name="Card caption"/>
+          <p:cNvSpPr txBox="1"/>
+          <p:nvPr/>
+        </p:nvSpPr>
+        <p:spPr>
+          <a:xfrm>
+            <a:off x="8001000" y="3752850"/>
+            <a:ext cx="3390900" cy="247650"/>
+          </a:xfrm>
+          <a:prstGeom prst="rect">
+            <a:avLst/>
+          </a:prstGeom>
+          <a:noFill/>
+        </p:spPr>
+        <p:txBody>
+          <a:bodyPr wrap="none" lIns="0" tIns="0" rIns="0" bIns="0" anchor="t" rtlCol="0">
+            <a:noAutofit/>
+          </a:bodyPr>
+          <a:lstStyle/>
+          <a:p>
+            <a:pPr algn="l">
+              <a:lnSpc>
+                <a:spcPts val="1950"/>
+              </a:lnSpc>
+              <a:spcBef>
+                <a:spcPts val="0"/>
+              </a:spcBef>
+              <a:spcAft>
+                <a:spcPts val="0"/>
+              </a:spcAft>
+              <a:buNone/>
+            </a:pPr>
+            <a:r>
+              <a:rPr lang="en-US" sz="1500" b="0" i="0" kern="0" dirty="0">
+                <a:solidFill>
+                  <a:schemeClr val="dk1"/>
+                </a:solidFill>
+                <a:latin typeface="Inter SemiBold"/>
+                <a:cs typeface="Inter SemiBold"/>
+              </a:rPr>
+              <a:t>deck.pptx </a:t>
+            </a:r>
+            <a:r>
+              <a:rPr lang="en-US" sz="1500" b="0" i="0" kern="0" dirty="0">
+                <a:solidFill>
+                  <a:schemeClr val="accent1"/>
+                </a:solidFill>
+                <a:latin typeface="Inter SemiBold"/>
+                <a:cs typeface="Inter SemiBold"/>
+              </a:rPr>
+              <a:t>· 11 native slides</a:t>
+            </a:r>
+            <a:endParaRPr lang="en-US" sz="1500" b="0" i="0" kern="0" dirty="0">
+              <a:solidFill>
+                <a:schemeClr val="accent1"/>
+              </a:solidFill>
+              <a:latin typeface="Inter SemiBold"/>
+              <a:cs typeface="Inter SemiBold"/>
+            </a:endParaRPr>
+          </a:p>
+        </p:txBody>
+      </p:sp>
+      <p:sp>
+        <p:nvSpPr>
+          <p:cNvPr id="7" name="Title"/>
           <p:cNvSpPr txBox="1"/>
           <p:nvPr/>
         </p:nvSpPr>
@@ -4945,7 +5036,7 @@
       </p:sp>
       <p:sp>
         <p:nvSpPr>
-          <p:cNvPr id="6" name="Subtitle"/>
+          <p:cNvPr id="8" name="Subtitle"/>
           <p:cNvSpPr txBox="1"/>
           <p:nvPr/>
         </p:nvSpPr>
@@ -4999,17 +5090,17 @@
       </p:sp>
       <p:pic>
         <p:nvPicPr>
-          <p:cNvPr id="7" name="Logo" descr="Slidekick"/>
+          <p:cNvPr id="9" name="Logo" descr="Slidekick"/>
           <p:cNvPicPr>
             <a:picLocks noChangeAspect="1"/>
           </p:cNvPicPr>
           <p:nvPr/>
         </p:nvPicPr>
         <p:blipFill>
-          <a:blip r:embed="rId2">
+          <a:blip r:embed="rId3">
             <a:extLst>
               <a:ext uri="{96DAC541-7B7A-43D3-8B79-37D633B846F1}">
-                <asvg:svgBlip xmlns:asvg="http://schemas.microsoft.com/office/drawing/2016/SVG/main" r:embed="rId3"/>
+                <asvg:svgBlip xmlns:asvg="http://schemas.microsoft.com/office/drawing/2016/SVG/main" r:embed="rId4"/>
               </a:ext>
             </a:extLst>
           </a:blip>

</xml_diff>